<commit_message>
feat: add deep dive slides for ACID and SQL Analysis
Added two deep dive slides to the presentation generation script based on
external resources:
1. The ACID transaction model (from the Cours_BDD repo).
2. SQL syntax for Data Analysis and Data Quality (from the LinkedIn Learning repo).
Regenerated the presentation to include these new slides.

Co-authored-by: ArthurStarks <137041166+ArthurStarks@users.noreply.github.com>
</commit_message>
<xml_diff>
--- a/Module2_Week1_Presentation.pptx
+++ b/Module2_Week1_Presentation.pptx
@@ -11,6 +11,8 @@
     <p:sldId id="259" r:id="rId10"/>
     <p:sldId id="260" r:id="rId11"/>
     <p:sldId id="261" r:id="rId12"/>
+    <p:sldId id="262" r:id="rId13"/>
+    <p:sldId id="263" r:id="rId14"/>
   </p:sldIdLst>
   <p:sldSz cx="9144000" cy="6858000" type="screen4x3"/>
   <p:notesSz cx="6858000" cy="9144000"/>
@@ -4056,6 +4058,418 @@
 </file>
 
 <file path=ppt/slides/slide6.xml><?xml version="1.0" encoding="utf-8"?>
+<p:sld xmlns:a="http://schemas.openxmlformats.org/drawingml/2006/main" xmlns:p="http://schemas.openxmlformats.org/presentationml/2006/main" xmlns:r="http://schemas.openxmlformats.org/officeDocument/2006/relationships">
+  <p:cSld>
+    <p:spTree>
+      <p:nvGrpSpPr>
+        <p:cNvPr id="1" name=""/>
+        <p:cNvGrpSpPr/>
+        <p:nvPr/>
+      </p:nvGrpSpPr>
+      <p:grpSpPr/>
+      <p:sp>
+        <p:nvSpPr>
+          <p:cNvPr id="2" name="Title 1"/>
+          <p:cNvSpPr>
+            <a:spLocks noGrp="1"/>
+          </p:cNvSpPr>
+          <p:nvPr>
+            <p:ph type="title"/>
+          </p:nvPr>
+        </p:nvSpPr>
+        <p:spPr/>
+        <p:txBody>
+          <a:bodyPr/>
+          <a:lstStyle/>
+          <a:p/>
+        </p:txBody>
+      </p:sp>
+      <p:sp>
+        <p:nvSpPr>
+          <p:cNvPr id="3" name="TextBox 2"/>
+          <p:cNvSpPr txBox="1"/>
+          <p:nvPr/>
+        </p:nvSpPr>
+        <p:spPr>
+          <a:xfrm>
+            <a:off x="457200" y="457200"/>
+            <a:ext cx="8229600" cy="914400"/>
+          </a:xfrm>
+          <a:prstGeom prst="rect">
+            <a:avLst/>
+          </a:prstGeom>
+          <a:noFill/>
+        </p:spPr>
+        <p:txBody>
+          <a:bodyPr wrap="none">
+            <a:spAutoFit/>
+          </a:bodyPr>
+          <a:lstStyle/>
+          <a:p>
+            <a:pPr algn="l">
+              <a:defRPr sz="2800" b="1">
+                <a:solidFill>
+                  <a:srgbClr val="ED1C24"/>
+                </a:solidFill>
+                <a:latin typeface="Calibri"/>
+              </a:defRPr>
+            </a:pPr>
+            <a:r>
+              <a:t>🔴 DEEP DIVE: Le Modèle ACID (Transactions)</a:t>
+            </a:r>
+          </a:p>
+        </p:txBody>
+      </p:sp>
+      <p:sp>
+        <p:nvSpPr>
+          <p:cNvPr id="4" name="TextBox 3"/>
+          <p:cNvSpPr txBox="1"/>
+          <p:nvPr/>
+        </p:nvSpPr>
+        <p:spPr>
+          <a:xfrm>
+            <a:off x="457200" y="1371600"/>
+            <a:ext cx="4114800" cy="4572000"/>
+          </a:xfrm>
+          <a:prstGeom prst="rect">
+            <a:avLst/>
+          </a:prstGeom>
+          <a:noFill/>
+        </p:spPr>
+        <p:txBody>
+          <a:bodyPr wrap="square">
+            <a:spAutoFit/>
+          </a:bodyPr>
+          <a:lstStyle/>
+          <a:p/>
+          <a:p>
+            <a:pPr>
+              <a:defRPr b="1" sz="2000"/>
+            </a:pPr>
+            <a:r>
+              <a:t>Garantir la fiabilité absolue</a:t>
+            </a:r>
+          </a:p>
+          <a:p>
+            <a:pPr lvl="1">
+              <a:defRPr sz="1600"/>
+            </a:pPr>
+            <a:r>
+              <a:t>- Atomicité : Une transaction passe entièrement ou est annulée (0 ou 100%).</a:t>
+            </a:r>
+            <a:br/>
+            <a:r>
+              <a:t>- Cohérence : Le Database Schema et les contraintes sont toujours respectés.</a:t>
+            </a:r>
+          </a:p>
+          <a:p>
+            <a:pPr>
+              <a:defRPr b="1" sz="2000">
+                <a:solidFill>
+                  <a:srgbClr val="ED1C24"/>
+                </a:solidFill>
+              </a:defRPr>
+            </a:pPr>
+            <a:r>
+              <a:t>Sécurité &amp; Isolation</a:t>
+            </a:r>
+          </a:p>
+          <a:p>
+            <a:pPr lvl="1">
+              <a:defRPr sz="1600"/>
+            </a:pPr>
+            <a:r>
+              <a:t>- Isolation : Les transactions simultanées n'interfèrent pas (Multi-users).</a:t>
+            </a:r>
+            <a:br/>
+            <a:r>
+              <a:t>- Durabilité : En cas de crash, les données validées sont sauvegardées.</a:t>
+            </a:r>
+          </a:p>
+        </p:txBody>
+      </p:sp>
+      <p:sp>
+        <p:nvSpPr>
+          <p:cNvPr id="5" name="Rectangle 4"/>
+          <p:cNvSpPr/>
+          <p:nvPr/>
+        </p:nvSpPr>
+        <p:spPr>
+          <a:xfrm>
+            <a:off x="5029200" y="1371600"/>
+            <a:ext cx="3657600" cy="4572000"/>
+          </a:xfrm>
+          <a:prstGeom prst="rect">
+            <a:avLst/>
+          </a:prstGeom>
+          <a:solidFill>
+            <a:srgbClr val="FFFFFF"/>
+          </a:solidFill>
+          <a:ln w="25400">
+            <a:solidFill>
+              <a:srgbClr val="ED1C24"/>
+            </a:solidFill>
+          </a:ln>
+        </p:spPr>
+        <p:style>
+          <a:lnRef idx="1">
+            <a:schemeClr val="accent1"/>
+          </a:lnRef>
+          <a:fillRef idx="3">
+            <a:schemeClr val="accent1"/>
+          </a:fillRef>
+          <a:effectRef idx="2">
+            <a:schemeClr val="accent1"/>
+          </a:effectRef>
+          <a:fontRef idx="minor">
+            <a:schemeClr val="lt1"/>
+          </a:fontRef>
+        </p:style>
+        <p:txBody>
+          <a:bodyPr rtlCol="0" anchor="ctr"/>
+          <a:lstStyle/>
+          <a:p>
+            <a:pPr algn="ctr">
+              <a:defRPr sz="1400" b="0">
+                <a:solidFill>
+                  <a:srgbClr val="282828"/>
+                </a:solidFill>
+                <a:latin typeface="Calibri"/>
+              </a:defRPr>
+            </a:pPr>
+            <a:r>
+              <a:t>[VISUEL KADEA]</a:t>
+            </a:r>
+            <a:br/>
+            <a:r>
+              <a:t>Schéma ACID.</a:t>
+            </a:r>
+            <a:br/>
+            <a:r>
+              <a:t>4 piliers supportant un temple grec (RDBMS).</a:t>
+            </a:r>
+            <a:br/>
+            <a:r>
+              <a:t>Chaque pilier porte une lettre A, C, I, D avec une icône de bouclier.</a:t>
+            </a:r>
+          </a:p>
+        </p:txBody>
+      </p:sp>
+    </p:spTree>
+  </p:cSld>
+  <p:clrMapOvr>
+    <a:masterClrMapping/>
+  </p:clrMapOvr>
+</p:sld>
+</file>
+
+<file path=ppt/slides/slide7.xml><?xml version="1.0" encoding="utf-8"?>
+<p:sld xmlns:a="http://schemas.openxmlformats.org/drawingml/2006/main" xmlns:p="http://schemas.openxmlformats.org/presentationml/2006/main" xmlns:r="http://schemas.openxmlformats.org/officeDocument/2006/relationships">
+  <p:cSld>
+    <p:spTree>
+      <p:nvGrpSpPr>
+        <p:cNvPr id="1" name=""/>
+        <p:cNvGrpSpPr/>
+        <p:nvPr/>
+      </p:nvGrpSpPr>
+      <p:grpSpPr/>
+      <p:sp>
+        <p:nvSpPr>
+          <p:cNvPr id="2" name="Title 1"/>
+          <p:cNvSpPr>
+            <a:spLocks noGrp="1"/>
+          </p:cNvSpPr>
+          <p:nvPr>
+            <p:ph type="title"/>
+          </p:nvPr>
+        </p:nvSpPr>
+        <p:spPr/>
+        <p:txBody>
+          <a:bodyPr/>
+          <a:lstStyle/>
+          <a:p/>
+        </p:txBody>
+      </p:sp>
+      <p:sp>
+        <p:nvSpPr>
+          <p:cNvPr id="3" name="TextBox 2"/>
+          <p:cNvSpPr txBox="1"/>
+          <p:nvPr/>
+        </p:nvSpPr>
+        <p:spPr>
+          <a:xfrm>
+            <a:off x="457200" y="457200"/>
+            <a:ext cx="8229600" cy="914400"/>
+          </a:xfrm>
+          <a:prstGeom prst="rect">
+            <a:avLst/>
+          </a:prstGeom>
+          <a:noFill/>
+        </p:spPr>
+        <p:txBody>
+          <a:bodyPr wrap="none">
+            <a:spAutoFit/>
+          </a:bodyPr>
+          <a:lstStyle/>
+          <a:p>
+            <a:pPr algn="l">
+              <a:defRPr sz="2800" b="1">
+                <a:solidFill>
+                  <a:srgbClr val="ED1C24"/>
+                </a:solidFill>
+                <a:latin typeface="Calibri"/>
+              </a:defRPr>
+            </a:pPr>
+            <a:r>
+              <a:t>🔴 DEEP DIVE: SQL Syntax pour l'Analyse (DBeaver)</a:t>
+            </a:r>
+          </a:p>
+        </p:txBody>
+      </p:sp>
+      <p:sp>
+        <p:nvSpPr>
+          <p:cNvPr id="4" name="TextBox 3"/>
+          <p:cNvSpPr txBox="1"/>
+          <p:nvPr/>
+        </p:nvSpPr>
+        <p:spPr>
+          <a:xfrm>
+            <a:off x="457200" y="1371600"/>
+            <a:ext cx="4114800" cy="4572000"/>
+          </a:xfrm>
+          <a:prstGeom prst="rect">
+            <a:avLst/>
+          </a:prstGeom>
+          <a:noFill/>
+        </p:spPr>
+        <p:txBody>
+          <a:bodyPr wrap="square">
+            <a:spAutoFit/>
+          </a:bodyPr>
+          <a:lstStyle/>
+          <a:p/>
+          <a:p>
+            <a:pPr>
+              <a:defRPr b="1" sz="2000"/>
+            </a:pPr>
+            <a:r>
+              <a:t>Nettoyage &amp; Data Quality</a:t>
+            </a:r>
+          </a:p>
+          <a:p>
+            <a:pPr lvl="1">
+              <a:defRPr sz="1600"/>
+            </a:pPr>
+            <a:r>
+              <a:t>- Gérer les 'Dirty Data' (doublons, formats mixtes, Missing Values).</a:t>
+            </a:r>
+            <a:br/>
+            <a:r>
+              <a:t>- SQL permet de transformer et filtrer massivement (Data Wrangling).</a:t>
+            </a:r>
+          </a:p>
+          <a:p>
+            <a:pPr>
+              <a:defRPr b="1" sz="2000">
+                <a:solidFill>
+                  <a:srgbClr val="ED1C24"/>
+                </a:solidFill>
+              </a:defRPr>
+            </a:pPr>
+            <a:r>
+              <a:t>Analyse Statistique &amp; Window Functions</a:t>
+            </a:r>
+          </a:p>
+          <a:p>
+            <a:pPr lvl="1">
+              <a:defRPr sz="1600"/>
+            </a:pPr>
+            <a:r>
+              <a:t>- Syntaxe avancée (PostgreSQL) : SELECT, JOIN, GROUP BY.</a:t>
+            </a:r>
+            <a:br/>
+            <a:r>
+              <a:t>- Fonctions de fenêtrage (OVER, PARTITION BY) pour des analyses de distribution.</a:t>
+            </a:r>
+          </a:p>
+        </p:txBody>
+      </p:sp>
+      <p:sp>
+        <p:nvSpPr>
+          <p:cNvPr id="5" name="Rectangle 4"/>
+          <p:cNvSpPr/>
+          <p:nvPr/>
+        </p:nvSpPr>
+        <p:spPr>
+          <a:xfrm>
+            <a:off x="5029200" y="1371600"/>
+            <a:ext cx="3657600" cy="4572000"/>
+          </a:xfrm>
+          <a:prstGeom prst="rect">
+            <a:avLst/>
+          </a:prstGeom>
+          <a:solidFill>
+            <a:srgbClr val="FFFFFF"/>
+          </a:solidFill>
+          <a:ln w="25400">
+            <a:solidFill>
+              <a:srgbClr val="ED1C24"/>
+            </a:solidFill>
+          </a:ln>
+        </p:spPr>
+        <p:style>
+          <a:lnRef idx="1">
+            <a:schemeClr val="accent1"/>
+          </a:lnRef>
+          <a:fillRef idx="3">
+            <a:schemeClr val="accent1"/>
+          </a:fillRef>
+          <a:effectRef idx="2">
+            <a:schemeClr val="accent1"/>
+          </a:effectRef>
+          <a:fontRef idx="minor">
+            <a:schemeClr val="lt1"/>
+          </a:fontRef>
+        </p:style>
+        <p:txBody>
+          <a:bodyPr rtlCol="0" anchor="ctr"/>
+          <a:lstStyle/>
+          <a:p>
+            <a:pPr algn="ctr">
+              <a:defRPr sz="1400" b="0">
+                <a:solidFill>
+                  <a:srgbClr val="282828"/>
+                </a:solidFill>
+                <a:latin typeface="Calibri"/>
+              </a:defRPr>
+            </a:pPr>
+            <a:r>
+              <a:t>[VISUEL KADEA]</a:t>
+            </a:r>
+            <a:br/>
+            <a:r>
+              <a:t>Split Screen.</a:t>
+            </a:r>
+            <a:br/>
+            <a:r>
+              <a:t>Haut : Un dataset brouillon ('Dirty').</a:t>
+            </a:r>
+            <a:br/>
+            <a:r>
+              <a:t>Bas : Bloc de code SQL (Syntaxe PostgreSQL/DBeaver) purifiant les données (Entonnoir Rouge).</a:t>
+            </a:r>
+          </a:p>
+        </p:txBody>
+      </p:sp>
+    </p:spTree>
+  </p:cSld>
+  <p:clrMapOvr>
+    <a:masterClrMapping/>
+  </p:clrMapOvr>
+</p:sld>
+</file>
+
+<file path=ppt/slides/slide8.xml><?xml version="1.0" encoding="utf-8"?>
 <p:sld xmlns:a="http://schemas.openxmlformats.org/drawingml/2006/main" xmlns:p="http://schemas.openxmlformats.org/presentationml/2006/main" xmlns:r="http://schemas.openxmlformats.org/officeDocument/2006/relationships">
   <p:cSld>
     <p:spTree>

</xml_diff>